<commit_message>
Reword fine-tuning takeaway in the presentation and README
</commit_message>
<xml_diff>
--- a/CodeRetriever_PRISM_2026.pptx
+++ b/CodeRetriever_PRISM_2026.pptx
@@ -118,33 +118,33 @@
   <p:extLst>
     <p:ext uri="{521415D9-36F7-43E2-AB2F-B90AF26B5E84}">
       <p14:sectionLst xmlns:p14="http://schemas.microsoft.com/office/powerpoint/2010/main">
-        <p14:section name="Introduction" id="{2934cb14-0807-9454-79cd-15030d4c4122}">
+        <p14:section name="Introduction" id="{0552d1b4-baf2-7644-52b8-a6aa967bd1e6}">
           <p14:sldIdLst>
             <p14:sldId id="256"/>
             <p14:sldId id="257"/>
             <p14:sldId id="258"/>
           </p14:sldIdLst>
         </p14:section>
-        <p14:section name="Approach" id="{d8022c3e-181a-913d-8748-2f205b0599da}">
+        <p14:section name="Approach" id="{05fc46e3-7b9f-7afd-0d84-30a285a15199}">
           <p14:sldIdLst>
             <p14:sldId id="259"/>
             <p14:sldId id="260"/>
           </p14:sldIdLst>
         </p14:section>
-        <p14:section name="Architecture" id="{7ea14d7a-ef78-7b7c-311f-757afbba7372}">
+        <p14:section name="Architecture" id="{5b1b0b9d-70d2-10a0-f895-0783fc38b683}">
           <p14:sldIdLst>
             <p14:sldId id="261"/>
             <p14:sldId id="262"/>
             <p14:sldId id="263"/>
           </p14:sldIdLst>
         </p14:section>
-        <p14:section name="Product" id="{fa8905ef-67f0-4e34-3839-ff39d549bd99}">
+        <p14:section name="Product" id="{9ada8334-1003-881e-23bd-7ee2f04ff2fc}">
           <p14:sldIdLst>
             <p14:sldId id="264"/>
             <p14:sldId id="265"/>
           </p14:sldIdLst>
         </p14:section>
-        <p14:section name="Wrap-up" id="{8bdf611f-3262-5835-a017-c9bc67edd3fe}">
+        <p14:section name="Wrap-up" id="{b900207f-35d7-d09a-acdf-87d1d6081d1e}">
           <p14:sldIdLst>
             <p14:sldId id="266"/>
             <p14:sldId id="267"/>
@@ -3348,7 +3348,7 @@
                   <a:schemeClr val="bg1"/>
                 </a:solidFill>
               </a:rPr>
-              <a:t>A strong base model beat fine-tuning</a:t>
+              <a:t>Measure first: the base model beat our fine-tune</a:t>
             </a:r>
             <a:endParaRPr lang="en-US" sz="3600" dirty="0"/>
           </a:p>
@@ -3451,7 +3451,7 @@
                   <a:schemeClr val="bg1"/>
                 </a:solidFill>
               </a:rPr>
-              <a:t>Small, well-trained embedders are already near the ceiling on APPS; naive fine-tuning on 1k examples hurt.</a:t>
+              <a:t>Fine-tuning on about 1k examples lowered both dev and test scores; the held-out dev set caught this before submission.</a:t>
             </a:r>
             <a:endParaRPr lang="en-US" sz="1400" dirty="0"/>
           </a:p>
@@ -3469,7 +3469,7 @@
                   <a:schemeClr val="bg1"/>
                 </a:solidFill>
               </a:rPr>
-              <a:t>Mined hard negatives in APPS include near-duplicate problems, which act as false negatives.</a:t>
+              <a:t>Some mined hard negatives were near-duplicate problems, which likely acted as false negatives.</a:t>
             </a:r>
             <a:endParaRPr lang="en-US" sz="1400" dirty="0"/>
           </a:p>

</xml_diff>

<commit_message>
Add model choice justification to the presentation
</commit_message>
<xml_diff>
--- a/CodeRetriever_PRISM_2026.pptx
+++ b/CodeRetriever_PRISM_2026.pptx
@@ -118,33 +118,33 @@
   <p:extLst>
     <p:ext uri="{521415D9-36F7-43E2-AB2F-B90AF26B5E84}">
       <p14:sectionLst xmlns:p14="http://schemas.microsoft.com/office/powerpoint/2010/main">
-        <p14:section name="Introduction" id="{0552d1b4-baf2-7644-52b8-a6aa967bd1e6}">
+        <p14:section name="Introduction" id="{c0242780-4e4d-28be-07f2-d67302c6a7ea}">
           <p14:sldIdLst>
             <p14:sldId id="256"/>
             <p14:sldId id="257"/>
             <p14:sldId id="258"/>
           </p14:sldIdLst>
         </p14:section>
-        <p14:section name="Approach" id="{05fc46e3-7b9f-7afd-0d84-30a285a15199}">
+        <p14:section name="Approach" id="{afa86f55-09cb-4fc4-1b54-39f78b3178af}">
           <p14:sldIdLst>
             <p14:sldId id="259"/>
             <p14:sldId id="260"/>
           </p14:sldIdLst>
         </p14:section>
-        <p14:section name="Architecture" id="{5b1b0b9d-70d2-10a0-f895-0783fc38b683}">
+        <p14:section name="Architecture" id="{92385a42-dd19-b7fb-05c8-3c7721a9306c}">
           <p14:sldIdLst>
             <p14:sldId id="261"/>
             <p14:sldId id="262"/>
             <p14:sldId id="263"/>
           </p14:sldIdLst>
         </p14:section>
-        <p14:section name="Product" id="{9ada8334-1003-881e-23bd-7ee2f04ff2fc}">
+        <p14:section name="Product" id="{42e9841f-01ea-a722-15e2-f03c1eb68e14}">
           <p14:sldIdLst>
             <p14:sldId id="264"/>
             <p14:sldId id="265"/>
           </p14:sldIdLst>
         </p14:section>
-        <p14:section name="Wrap-up" id="{b900207f-35d7-d09a-acdf-87d1d6081d1e}">
+        <p14:section name="Wrap-up" id="{31aeb8e2-567e-b73a-09e3-dedb6c332344}">
           <p14:sldIdLst>
             <p14:sldId id="266"/>
             <p14:sldId id="267"/>
@@ -5033,14 +5033,113 @@
       </p:graphicFrame>
       <p:sp>
         <p:nvSpPr>
-          <p:cNvPr id="5" name="model notes"/>
+          <p:cNvPr id="5" name="why card"/>
+          <p:cNvSpPr/>
+          <p:nvPr/>
+        </p:nvSpPr>
+        <p:spPr>
+          <a:xfrm>
+            <a:off x="7315200" y="1737360"/>
+            <a:ext cx="4251960" cy="2148840"/>
+          </a:xfrm>
+          <a:prstGeom prst="roundRect">
+            <a:avLst>
+              <a:gd name="adj" fmla="val 5106"/>
+            </a:avLst>
+          </a:prstGeom>
+          <a:solidFill>
+            <a:srgbClr val="161616"/>
+          </a:solidFill>
+          <a:ln w="9525">
+            <a:solidFill>
+              <a:srgbClr val="333333"/>
+            </a:solidFill>
+            <a:prstDash val="solid"/>
+          </a:ln>
+        </p:spPr>
+      </p:sp>
+      <p:sp>
+        <p:nvSpPr>
+          <p:cNvPr id="6" name="why head"/>
           <p:cNvSpPr txBox="1"/>
           <p:nvPr/>
         </p:nvSpPr>
         <p:spPr>
           <a:xfrm>
-            <a:off x="7315200" y="1828800"/>
-            <a:ext cx="4251960" cy="4114800"/>
+            <a:off x="7589520" y="1920240"/>
+            <a:ext cx="3749040" cy="365760"/>
+          </a:xfrm>
+          <a:prstGeom prst="rect">
+            <a:avLst/>
+          </a:prstGeom>
+          <a:noFill/>
+          <a:ln/>
+        </p:spPr>
+        <p:txBody>
+          <a:bodyPr wrap="square" lIns="0" tIns="0" rIns="0" bIns="0" rtlCol="0" anchor="t"/>
+          <a:lstStyle/>
+          <a:p>
+            <a:pPr indent="0" marL="0">
+              <a:buNone/>
+            </a:pPr>
+            <a:r>
+              <a:rPr lang="en-US" sz="1600" b="1" dirty="0">
+                <a:solidFill>
+                  <a:schemeClr val="bg1"/>
+                </a:solidFill>
+              </a:rPr>
+              <a:t>Why EmbeddingGemma-300m</a:t>
+            </a:r>
+            <a:endParaRPr lang="en-US" sz="1600" dirty="0"/>
+          </a:p>
+        </p:txBody>
+      </p:sp>
+      <p:sp>
+        <p:nvSpPr>
+          <p:cNvPr id="7" name="why body"/>
+          <p:cNvSpPr txBox="1"/>
+          <p:nvPr/>
+        </p:nvSpPr>
+        <p:spPr>
+          <a:xfrm>
+            <a:off x="7589520" y="2331720"/>
+            <a:ext cx="3749040" cy="1828800"/>
+          </a:xfrm>
+          <a:prstGeom prst="rect">
+            <a:avLst/>
+          </a:prstGeom>
+          <a:noFill/>
+          <a:ln/>
+        </p:spPr>
+        <p:txBody>
+          <a:bodyPr wrap="square" lIns="0" tIns="0" rIns="0" bIns="0" rtlCol="0" anchor="t"/>
+          <a:lstStyle/>
+          <a:p>
+            <a:pPr indent="0" marL="0">
+              <a:buNone/>
+            </a:pPr>
+            <a:r>
+              <a:rPr lang="en-US" sz="1300" dirty="0">
+                <a:solidFill>
+                  <a:schemeClr val="bg2"/>
+                </a:solidFill>
+              </a:rPr>
+              <a:t>Chosen for the best accuracy at 300M parameters (84.05 vs 75.92 for a model twice its size), CPU-friendly, and a single embedding space across CPU and GPU. Larger code embedders gain only ~1–3 points at several times the CPU cost, and some are non-commercial.</a:t>
+            </a:r>
+            <a:endParaRPr lang="en-US" sz="1300" dirty="0"/>
+          </a:p>
+        </p:txBody>
+      </p:sp>
+      <p:sp>
+        <p:nvSpPr>
+          <p:cNvPr id="8" name="model notes"/>
+          <p:cNvSpPr txBox="1"/>
+          <p:nvPr/>
+        </p:nvSpPr>
+        <p:spPr>
+          <a:xfrm>
+            <a:off x="7315200" y="4206240"/>
+            <a:ext cx="4251960" cy="1828800"/>
           </a:xfrm>
           <a:prstGeom prst="rect">
             <a:avLst/>
@@ -5060,14 +5159,14 @@
               <a:buChar char="•"/>
             </a:pPr>
             <a:r>
-              <a:rPr lang="en-US" sz="1500" dirty="0">
+              <a:rPr lang="en-US" sz="1400" dirty="0">
                 <a:solidFill>
                   <a:schemeClr val="bg1"/>
                 </a:solidFill>
               </a:rPr>
-              <a:t>Benchmarked two strong small embedding models; our setup reproduced the published MTEB scores (84.39 and 75.34).</a:t>
-            </a:r>
-            <a:endParaRPr lang="en-US" sz="1500" dirty="0"/>
+              <a:t>Our setup reproduced the published MTEB scores (84.39 and 75.34).</a:t>
+            </a:r>
+            <a:endParaRPr lang="en-US" sz="1400" dirty="0"/>
           </a:p>
           <a:p>
             <a:pPr marL="342900" indent="-342900">
@@ -5078,14 +5177,14 @@
               <a:buChar char="•"/>
             </a:pPr>
             <a:r>
-              <a:rPr lang="en-US" sz="1500" dirty="0">
+              <a:rPr lang="en-US" sz="1400" dirty="0">
                 <a:solidFill>
                   <a:schemeClr val="bg1"/>
                 </a:solidFill>
               </a:rPr>
-              <a:t>Fine-tuned EmbeddingGemma on the APPS train split with mined hard negatives (1,079 tuples, 161 min on the laptop GPU).</a:t>
-            </a:r>
-            <a:endParaRPr lang="en-US" sz="1500" dirty="0"/>
+              <a:t>Our fine-tune lost on dev (76.28 vs 79.41) and test, so the base model was kept.</a:t>
+            </a:r>
+            <a:endParaRPr lang="en-US" sz="1400" dirty="0"/>
           </a:p>
           <a:p>
             <a:pPr marL="342900" indent="-342900">
@@ -5096,32 +5195,14 @@
               <a:buChar char="•"/>
             </a:pPr>
             <a:r>
-              <a:rPr lang="en-US" sz="1500" dirty="0">
+              <a:rPr lang="en-US" sz="1400" dirty="0">
                 <a:solidFill>
                   <a:schemeClr val="bg1"/>
                 </a:solidFill>
               </a:rPr>
-              <a:t>The fine-tune lost on the held-out dev set (76.28 vs 79.41) and on test, so the base model was kept.</a:t>
-            </a:r>
-            <a:endParaRPr lang="en-US" sz="1500" dirty="0"/>
-          </a:p>
-          <a:p>
-            <a:pPr marL="342900" indent="-342900">
-              <a:spcAft>
-                <a:spcPts val="800"/>
-              </a:spcAft>
-              <a:buSzPct val="100000"/>
-              <a:buChar char="•"/>
-            </a:pPr>
-            <a:r>
-              <a:rPr lang="en-US" sz="1500" dirty="0">
-                <a:solidFill>
-                  <a:schemeClr val="bg1"/>
-                </a:solidFill>
-              </a:rPr>
-              <a:t>Test data was never used for training or for choosing the model.</a:t>
-            </a:r>
-            <a:endParaRPr lang="en-US" sz="1500" dirty="0"/>
+              <a:t>Test data was never used for training or model choice.</a:t>
+            </a:r>
+            <a:endParaRPr lang="en-US" sz="1400" dirty="0"/>
           </a:p>
         </p:txBody>
       </p:sp>

</xml_diff>